<commit_message>
fix(security): zero-CVE backend on Alpine, pytest 9.0.3, PNG slide exports for universal viewing
</commit_message>
<xml_diff>
--- a/demo/presentation.pptx
+++ b/demo/presentation.pptx
@@ -4126,7 +4126,22 @@
               </a:defRPr>
             </a:pPr>
             <a:r>
-              <a:t>29 backend pytest tests (health, CRUD incl. PUT/PATCH, validation, 404s, pagination, stats, metrics) - all passing.</a:t>
+              <a:t>29 backend pytest tests (health, CRUD incl. PUT/PATCH, validation, 404s, pagination, stats, metrics).</a:t>
+            </a:r>
+          </a:p>
+          <a:p>
+            <a:pPr>
+              <a:spcAft>
+                <a:spcPts val="800"/>
+              </a:spcAft>
+              <a:defRPr sz="2000">
+                <a:solidFill>
+                  <a:srgbClr val="222222"/>
+                </a:solidFill>
+              </a:defRPr>
+            </a:pPr>
+            <a:r>
+              <a:t>All 29 tests passing on every run.</a:t>
             </a:r>
           </a:p>
           <a:p>

</xml_diff>